<commit_message>
docs: refresh project overview and presentation assets
</commit_message>
<xml_diff>
--- a/docs/presentations/NOSTOS_개발완료보고서_최종_표지포함20p.pptx
+++ b/docs/presentations/NOSTOS_개발완료보고서_최종_표지포함20p.pptx
@@ -2,32 +2,32 @@
 <file path=ppt/presentation.xml><?xml version="1.0" encoding="utf-8"?>
 <p:presentation xmlns:p="http://schemas.openxmlformats.org/presentationml/2006/main">
   <p:sldMasterIdLst>
-    <p:sldMasterId xmlns:r="http://schemas.openxmlformats.org/officeDocument/2006/relationships" id="2147483648" r:id="R0d0b14be8d454ad2"/>
+    <p:sldMasterId xmlns:r="http://schemas.openxmlformats.org/officeDocument/2006/relationships" id="2147483648" r:id="R962dcde8be65439f"/>
   </p:sldMasterIdLst>
   <p:notesMasterIdLst>
-    <p:notesMasterId xmlns:r="http://schemas.openxmlformats.org/officeDocument/2006/relationships" r:id="Rc4202178e2ba4680"/>
+    <p:notesMasterId xmlns:r="http://schemas.openxmlformats.org/officeDocument/2006/relationships" r:id="Ree5870f86f184401"/>
   </p:notesMasterIdLst>
   <p:sldIdLst>
-    <p:sldId xmlns:r="http://schemas.openxmlformats.org/officeDocument/2006/relationships" id="256" r:id="Rd4296854e5ac4c27"/>
-    <p:sldId xmlns:r="http://schemas.openxmlformats.org/officeDocument/2006/relationships" id="257" r:id="R1c82179c39bd47fc"/>
-    <p:sldId xmlns:r="http://schemas.openxmlformats.org/officeDocument/2006/relationships" id="258" r:id="R44e1bba2f8b449af"/>
-    <p:sldId xmlns:r="http://schemas.openxmlformats.org/officeDocument/2006/relationships" id="259" r:id="R305eefbd9f364fcc"/>
-    <p:sldId xmlns:r="http://schemas.openxmlformats.org/officeDocument/2006/relationships" id="260" r:id="R839534ac8f4c4b25"/>
-    <p:sldId xmlns:r="http://schemas.openxmlformats.org/officeDocument/2006/relationships" id="261" r:id="Reb27d8dbbc534f4a"/>
-    <p:sldId xmlns:r="http://schemas.openxmlformats.org/officeDocument/2006/relationships" id="262" r:id="R1c9defe058554347"/>
-    <p:sldId xmlns:r="http://schemas.openxmlformats.org/officeDocument/2006/relationships" id="263" r:id="Rf7ab496e572f41bb"/>
-    <p:sldId xmlns:r="http://schemas.openxmlformats.org/officeDocument/2006/relationships" id="264" r:id="Ra2cb0e2a614944cb"/>
-    <p:sldId xmlns:r="http://schemas.openxmlformats.org/officeDocument/2006/relationships" id="265" r:id="R582f8e76ab644252"/>
-    <p:sldId xmlns:r="http://schemas.openxmlformats.org/officeDocument/2006/relationships" id="266" r:id="R3387b5d7a7284d27"/>
-    <p:sldId xmlns:r="http://schemas.openxmlformats.org/officeDocument/2006/relationships" id="267" r:id="R0695223bf71e47d3"/>
-    <p:sldId xmlns:r="http://schemas.openxmlformats.org/officeDocument/2006/relationships" id="268" r:id="Rd9775ba30cbc41ab"/>
-    <p:sldId xmlns:r="http://schemas.openxmlformats.org/officeDocument/2006/relationships" id="269" r:id="R172b3b2050a54a1a"/>
-    <p:sldId xmlns:r="http://schemas.openxmlformats.org/officeDocument/2006/relationships" id="270" r:id="R3d47f910ebaa4cff"/>
-    <p:sldId xmlns:r="http://schemas.openxmlformats.org/officeDocument/2006/relationships" id="271" r:id="R1e12e94e95444636"/>
-    <p:sldId xmlns:r="http://schemas.openxmlformats.org/officeDocument/2006/relationships" id="272" r:id="Rfc19dc29a7314203"/>
-    <p:sldId xmlns:r="http://schemas.openxmlformats.org/officeDocument/2006/relationships" id="273" r:id="Re28e3e27680249a5"/>
-    <p:sldId xmlns:r="http://schemas.openxmlformats.org/officeDocument/2006/relationships" id="274" r:id="Rf1c3ed919a5845d8"/>
-    <p:sldId xmlns:r="http://schemas.openxmlformats.org/officeDocument/2006/relationships" id="275" r:id="R34c7da4de6534a4b"/>
+    <p:sldId xmlns:r="http://schemas.openxmlformats.org/officeDocument/2006/relationships" id="256" r:id="R1e4c4780ce174c54"/>
+    <p:sldId xmlns:r="http://schemas.openxmlformats.org/officeDocument/2006/relationships" id="257" r:id="R18d1495250b74c3b"/>
+    <p:sldId xmlns:r="http://schemas.openxmlformats.org/officeDocument/2006/relationships" id="258" r:id="R93cd1303e93f445c"/>
+    <p:sldId xmlns:r="http://schemas.openxmlformats.org/officeDocument/2006/relationships" id="259" r:id="Rc77bf511e7e64a43"/>
+    <p:sldId xmlns:r="http://schemas.openxmlformats.org/officeDocument/2006/relationships" id="260" r:id="R5a9c478fcc754bd0"/>
+    <p:sldId xmlns:r="http://schemas.openxmlformats.org/officeDocument/2006/relationships" id="261" r:id="Rea6d7c59b6ff45b7"/>
+    <p:sldId xmlns:r="http://schemas.openxmlformats.org/officeDocument/2006/relationships" id="262" r:id="Rb38d7eb05a474607"/>
+    <p:sldId xmlns:r="http://schemas.openxmlformats.org/officeDocument/2006/relationships" id="263" r:id="Re48bb8a8cb2e4dd8"/>
+    <p:sldId xmlns:r="http://schemas.openxmlformats.org/officeDocument/2006/relationships" id="264" r:id="R6aaa83bb241046ca"/>
+    <p:sldId xmlns:r="http://schemas.openxmlformats.org/officeDocument/2006/relationships" id="265" r:id="R1e3463a4446748be"/>
+    <p:sldId xmlns:r="http://schemas.openxmlformats.org/officeDocument/2006/relationships" id="266" r:id="Rf1844bcefbba4024"/>
+    <p:sldId xmlns:r="http://schemas.openxmlformats.org/officeDocument/2006/relationships" id="267" r:id="Rc8391df373414703"/>
+    <p:sldId xmlns:r="http://schemas.openxmlformats.org/officeDocument/2006/relationships" id="268" r:id="Rf4d17a9fc81a41f2"/>
+    <p:sldId xmlns:r="http://schemas.openxmlformats.org/officeDocument/2006/relationships" id="269" r:id="R26e95446f8394a7b"/>
+    <p:sldId xmlns:r="http://schemas.openxmlformats.org/officeDocument/2006/relationships" id="270" r:id="R8b59b167cc0d4d30"/>
+    <p:sldId xmlns:r="http://schemas.openxmlformats.org/officeDocument/2006/relationships" id="271" r:id="R3deeb13d0bef4ade"/>
+    <p:sldId xmlns:r="http://schemas.openxmlformats.org/officeDocument/2006/relationships" id="272" r:id="R02bb76e0bc9041ed"/>
+    <p:sldId xmlns:r="http://schemas.openxmlformats.org/officeDocument/2006/relationships" id="273" r:id="R3ec28db6d3674e03"/>
+    <p:sldId xmlns:r="http://schemas.openxmlformats.org/officeDocument/2006/relationships" id="274" r:id="R66eb4024a9a04432"/>
+    <p:sldId xmlns:r="http://schemas.openxmlformats.org/officeDocument/2006/relationships" id="275" r:id="Rc21501869f734be4"/>
   </p:sldIdLst>
   <p:sldSz cx="12192000" cy="6858000"/>
   <p:notesSz cx="6858000" cy="9144000"/>
@@ -1566,12 +1566,22 @@
           <a:lstStyle xmlns:a="http://schemas.openxmlformats.org/drawingml/2006/main"/>
           <a:p xmlns:a="http://schemas.openxmlformats.org/drawingml/2006/main">
             <a:r>
-              <a:t>실명 정보가 제공되지 않아 역할 기준으로 업무 분장을 정리.</a:t>
+              <a:t>마무리: NOSTOS의 핵심 가치와 개발 역할, 결과 링크를 한 장에 정리.</a:t>
             </a:r>
           </a:p>
           <a:p xmlns:a="http://schemas.openxmlformats.org/drawingml/2006/main">
             <a:r>
               <a:t>[Sources]</a:t>
+            </a:r>
+          </a:p>
+          <a:p xmlns:a="http://schemas.openxmlformats.org/drawingml/2006/main">
+            <a:r>
+              <a:t>- Source code: https://github.com/snowflake-rider/nostos</a:t>
+            </a:r>
+          </a:p>
+          <a:p xmlns:a="http://schemas.openxmlformats.org/drawingml/2006/main">
+            <a:r>
+              <a:t>- Contest preliminary demo video: https://www.youtube.com/watch?v=r-7fjGOm1hw&amp;feature=youtu.be</a:t>
             </a:r>
           </a:p>
           <a:p xmlns:a="http://schemas.openxmlformats.org/drawingml/2006/main">
@@ -2304,7 +2314,7 @@
   </p:cSld>
   <p:clrMap bg1="lt1" tx1="dk1" bg2="lt2" tx2="dk2" accent1="accent1" accent2="accent2" accent3="accent3" accent4="accent4" accent5="accent5" accent6="accent6" hlink="hlink" folHlink="folHlink"/>
   <p:sldLayoutIdLst>
-    <p:sldLayoutId xmlns:r="http://schemas.openxmlformats.org/officeDocument/2006/relationships" id="2147483649" r:id="R37dc9ad4a6694595"/>
+    <p:sldLayoutId xmlns:r="http://schemas.openxmlformats.org/officeDocument/2006/relationships" id="2147483649" r:id="R86d6803ad5914ea2"/>
   </p:sldLayoutIdLst>
   <p:txStyles>
     <p:titleStyle>
@@ -3572,7 +3582,7 @@
           <p:nvPr/>
         </p:nvPicPr>
         <p:blipFill>
-          <a:blip xmlns:r="http://schemas.openxmlformats.org/officeDocument/2006/relationships" xmlns:a="http://schemas.openxmlformats.org/drawingml/2006/main" r:embed="R65c746e61e134e3a"/>
+          <a:blip xmlns:r="http://schemas.openxmlformats.org/officeDocument/2006/relationships" xmlns:a="http://schemas.openxmlformats.org/drawingml/2006/main" r:embed="Re340eed0c9934134"/>
           <a:stretch xmlns:a="http://schemas.openxmlformats.org/drawingml/2006/main"/>
         </p:blipFill>
         <p:spPr>
@@ -19534,7 +19544,7 @@
           <p:nvPr/>
         </p:nvPicPr>
         <p:blipFill>
-          <a:blip xmlns:r="http://schemas.openxmlformats.org/officeDocument/2006/relationships" xmlns:a="http://schemas.openxmlformats.org/drawingml/2006/main" r:embed="R86b93e51327642ba"/>
+          <a:blip xmlns:r="http://schemas.openxmlformats.org/officeDocument/2006/relationships" xmlns:a="http://schemas.openxmlformats.org/drawingml/2006/main" r:embed="Ra0238afb929b41b9"/>
           <a:stretch xmlns:a="http://schemas.openxmlformats.org/drawingml/2006/main"/>
         </p:blipFill>
         <p:spPr>
@@ -19787,7 +19797,7 @@
                 <a:ea typeface="Apple SD Gothic Neo"/>
                 <a:cs typeface="Apple SD Gothic Neo"/>
               </a:rPr>
-              <a:t>세 담당 영역을 공통 프로토콜과 통합 시험으로 연결했습니다</a:t>
+              <a:t>세 라이더, 하나의 안전 상태</a:t>
             </a:r>
           </a:p>
         </p:txBody>
@@ -19846,7 +19856,7 @@
                 <a:ea typeface="Apple SD Gothic Neo"/>
                 <a:cs typeface="Apple SD Gothic Neo"/>
               </a:rPr>
-              <a:t>팀원이 작성한 기능을 현재 코드 기준의 역할 단위로 재정리했습니다</a:t>
+              <a:t>NOSTOS는 주행 중 화면 의존을 줄이고 필요한 신호를 팀 전체에 공유합니다</a:t>
             </a:r>
           </a:p>
         </p:txBody>
@@ -19984,7 +19994,7 @@
         </p:nvSpPr>
         <p:spPr>
           <a:xfrm xmlns:a="http://schemas.openxmlformats.org/drawingml/2006/main">
-            <a:off x="400050" y="2495550"/>
+            <a:off x="400050" y="2171700"/>
             <a:ext cx="3200400" cy="304800"/>
           </a:xfrm>
           <a:prstGeom xmlns:a="http://schemas.openxmlformats.org/drawingml/2006/main" prst="rect">
@@ -20006,7 +20016,7 @@
               <a:buNone/>
               <a:defRPr sz="1800" b="1">
                 <a:solidFill>
-                  <a:srgbClr val="071A2B"/>
+                  <a:srgbClr val="6DCBF4"/>
                 </a:solidFill>
                 <a:latin typeface="Apple SD Gothic Neo"/>
                 <a:ea typeface="Apple SD Gothic Neo"/>
@@ -20016,13 +20026,13 @@
             <a:r>
               <a:rPr sz="1800" b="1">
                 <a:solidFill>
-                  <a:srgbClr val="071A2B"/>
-                </a:solidFill>
-                <a:latin typeface="Apple SD Gothic Neo"/>
-                <a:ea typeface="Apple SD Gothic Neo"/>
-                <a:cs typeface="Apple SD Gothic Neo"/>
-              </a:rPr>
-              <a:t>안전 감지</a:t>
+                  <a:srgbClr val="6DCBF4"/>
+                </a:solidFill>
+                <a:latin typeface="Apple SD Gothic Neo"/>
+                <a:ea typeface="Apple SD Gothic Neo"/>
+                <a:cs typeface="Apple SD Gothic Neo"/>
+              </a:rPr>
+              <a:t/>
             </a:r>
           </a:p>
         </p:txBody>
@@ -20043,15 +20053,13 @@
         </p:nvSpPr>
         <p:spPr>
           <a:xfrm xmlns:a="http://schemas.openxmlformats.org/drawingml/2006/main">
-            <a:off x="400050" y="2990850"/>
-            <a:ext cx="3200400" cy="2057400"/>
-          </a:xfrm>
-          <a:prstGeom xmlns:a="http://schemas.openxmlformats.org/drawingml/2006/main" prst="rect">
-            <a:avLst/>
-          </a:prstGeom>
-          <a:solidFill xmlns:a="http://schemas.openxmlformats.org/drawingml/2006/main">
-            <a:srgbClr val="F3F6F8"/>
-          </a:solidFill>
+            <a:off x="400050" y="3333750"/>
+            <a:ext cx="3200400" cy="1714500"/>
+          </a:xfrm>
+          <a:prstGeom xmlns:a="http://schemas.openxmlformats.org/drawingml/2006/main" prst="rect">
+            <a:avLst/>
+          </a:prstGeom>
+          <a:noFill xmlns:a="http://schemas.openxmlformats.org/drawingml/2006/main"/>
           <a:ln xmlns:a="http://schemas.openxmlformats.org/drawingml/2006/main" w="0">
             <a:noFill/>
             <a:prstDash val="solid"/>
@@ -20074,7 +20082,7 @@
         </p:nvSpPr>
         <p:spPr>
           <a:xfrm xmlns:a="http://schemas.openxmlformats.org/drawingml/2006/main">
-            <a:off x="628650" y="3276600"/>
+            <a:off x="628650" y="3600450"/>
             <a:ext cx="2743200" cy="571500"/>
           </a:xfrm>
           <a:prstGeom xmlns:a="http://schemas.openxmlformats.org/drawingml/2006/main" prst="rect">
@@ -20112,7 +20120,7 @@
                 <a:ea typeface="Apple SD Gothic Neo"/>
                 <a:cs typeface="Apple SD Gothic Neo"/>
               </a:rPr>
-              <a:t>MPU6050 낙상 판단</a:t>
+              <a:t/>
             </a:r>
           </a:p>
         </p:txBody>
@@ -20133,8 +20141,8 @@
         </p:nvSpPr>
         <p:spPr>
           <a:xfrm xmlns:a="http://schemas.openxmlformats.org/drawingml/2006/main">
-            <a:off x="628650" y="4057650"/>
-            <a:ext cx="2743200" cy="685800"/>
+            <a:off x="628650" y="4324350"/>
+            <a:ext cx="2743200" cy="533400"/>
           </a:xfrm>
           <a:prstGeom xmlns:a="http://schemas.openxmlformats.org/drawingml/2006/main" prst="rect">
             <a:avLst/>
@@ -20171,31 +20179,7 @@
                 <a:ea typeface="Apple SD Gothic Neo"/>
                 <a:cs typeface="Apple SD Gothic Neo"/>
               </a:rPr>
-              <a:t>Calibration·충격·자세·회전</a:t>
-            </a:r>
-          </a:p>
-          <a:p xmlns:a="http://schemas.openxmlformats.org/drawingml/2006/main">
-            <a:pPr algn="ctr">
-              <a:buNone/>
-              <a:defRPr sz="1350" b="0">
-                <a:solidFill>
-                  <a:srgbClr val="5B6472"/>
-                </a:solidFill>
-                <a:latin typeface="Apple SD Gothic Neo"/>
-                <a:ea typeface="Apple SD Gothic Neo"/>
-                <a:cs typeface="Apple SD Gothic Neo"/>
-              </a:defRPr>
-            </a:pPr>
-            <a:r>
-              <a:rPr sz="1350" b="0">
-                <a:solidFill>
-                  <a:srgbClr val="5B6472"/>
-                </a:solidFill>
-                <a:latin typeface="Apple SD Gothic Neo"/>
-                <a:ea typeface="Apple SD Gothic Neo"/>
-                <a:cs typeface="Apple SD Gothic Neo"/>
-              </a:rPr>
-              <a:t>Safety Service·Host Test</a:t>
+              <a:t/>
             </a:r>
           </a:p>
         </p:txBody>
@@ -20304,7 +20288,7 @@
         </p:nvSpPr>
         <p:spPr>
           <a:xfrm xmlns:a="http://schemas.openxmlformats.org/drawingml/2006/main">
-            <a:off x="4257675" y="2495550"/>
+            <a:off x="4257675" y="2171700"/>
             <a:ext cx="3200400" cy="304800"/>
           </a:xfrm>
           <a:prstGeom xmlns:a="http://schemas.openxmlformats.org/drawingml/2006/main" prst="rect">
@@ -20326,6 +20310,94 @@
               <a:buNone/>
               <a:defRPr sz="1800" b="1">
                 <a:solidFill>
+                  <a:srgbClr val="14B8A6"/>
+                </a:solidFill>
+                <a:latin typeface="Apple SD Gothic Neo"/>
+                <a:ea typeface="Apple SD Gothic Neo"/>
+                <a:cs typeface="Apple SD Gothic Neo"/>
+              </a:defRPr>
+            </a:pPr>
+            <a:r>
+              <a:rPr sz="1800" b="1">
+                <a:solidFill>
+                  <a:srgbClr val="14B8A6"/>
+                </a:solidFill>
+                <a:latin typeface="Apple SD Gothic Neo"/>
+                <a:ea typeface="Apple SD Gothic Neo"/>
+                <a:cs typeface="Apple SD Gothic Neo"/>
+              </a:rPr>
+              <a:t/>
+            </a:r>
+          </a:p>
+        </p:txBody>
+      </p:sp>
+      <p:sp>
+        <p:nvSpPr>
+          <p:cNvPr id="14" name="slide3-panel-02">
+            <a:extLst xmlns:a="http://schemas.openxmlformats.org/drawingml/2006/main">
+              <a:ext uri="{FF2B5EF4-FFF2-40B4-BE49-F238E27FC236}">
+                <a16:creationId xmlns:a16="http://schemas.microsoft.com/office/drawing/2014/main" id="{3889836B-4F4B-43AC-9B8A-7622318EF3F9}"/>
+              </a:ext>
+            </a:extLst>
+          </p:cNvPr>
+          <p:cNvSpPr>
+            <a:spLocks xmlns:a="http://schemas.openxmlformats.org/drawingml/2006/main" noGrp="1"/>
+          </p:cNvSpPr>
+          <p:nvPr/>
+        </p:nvSpPr>
+        <p:spPr>
+          <a:xfrm xmlns:a="http://schemas.openxmlformats.org/drawingml/2006/main">
+            <a:off x="4257675" y="3333750"/>
+            <a:ext cx="3200400" cy="1714500"/>
+          </a:xfrm>
+          <a:prstGeom xmlns:a="http://schemas.openxmlformats.org/drawingml/2006/main" prst="rect">
+            <a:avLst/>
+          </a:prstGeom>
+          <a:noFill xmlns:a="http://schemas.openxmlformats.org/drawingml/2006/main"/>
+          <a:ln xmlns:a="http://schemas.openxmlformats.org/drawingml/2006/main" w="0">
+            <a:noFill/>
+            <a:prstDash val="solid"/>
+          </a:ln>
+        </p:spPr>
+      </p:sp>
+      <p:sp>
+        <p:nvSpPr>
+          <p:cNvPr id="15" name="slide3-card-title-02">
+            <a:extLst xmlns:a="http://schemas.openxmlformats.org/drawingml/2006/main">
+              <a:ext uri="{FF2B5EF4-FFF2-40B4-BE49-F238E27FC236}">
+                <a16:creationId xmlns:a16="http://schemas.microsoft.com/office/drawing/2014/main" id="{1287FDDF-BCAD-4F43-B0B0-7BED9E28DC2B}"/>
+              </a:ext>
+            </a:extLst>
+          </p:cNvPr>
+          <p:cNvSpPr>
+            <a:spLocks xmlns:a="http://schemas.openxmlformats.org/drawingml/2006/main" noGrp="1"/>
+          </p:cNvSpPr>
+          <p:nvPr/>
+        </p:nvSpPr>
+        <p:spPr>
+          <a:xfrm xmlns:a="http://schemas.openxmlformats.org/drawingml/2006/main">
+            <a:off x="1428750" y="2647950"/>
+            <a:ext cx="9334500" cy="1066800"/>
+          </a:xfrm>
+          <a:prstGeom xmlns:a="http://schemas.openxmlformats.org/drawingml/2006/main" prst="rect">
+            <a:avLst/>
+          </a:prstGeom>
+          <a:noFill xmlns:a="http://schemas.openxmlformats.org/drawingml/2006/main"/>
+          <a:ln xmlns:a="http://schemas.openxmlformats.org/drawingml/2006/main" w="0">
+            <a:noFill/>
+            <a:prstDash val="solid"/>
+          </a:ln>
+        </p:spPr>
+        <p:txBody>
+          <a:bodyPr xmlns:a="http://schemas.openxmlformats.org/drawingml/2006/main" wrap="square" lIns="0" tIns="0" rIns="0" bIns="0" anchor="t">
+            <a:noAutofit/>
+          </a:bodyPr>
+          <a:lstStyle xmlns:a="http://schemas.openxmlformats.org/drawingml/2006/main"/>
+          <a:p xmlns:a="http://schemas.openxmlformats.org/drawingml/2006/main">
+            <a:pPr algn="ctr">
+              <a:buNone/>
+              <a:defRPr sz="3000" b="1">
+                <a:solidFill>
                   <a:srgbClr val="071A2B"/>
                 </a:solidFill>
                 <a:latin typeface="Apple SD Gothic Neo"/>
@@ -20334,7 +20406,7 @@
               </a:defRPr>
             </a:pPr>
             <a:r>
-              <a:rPr sz="1800" b="1">
+              <a:rPr sz="3000" b="1">
                 <a:solidFill>
                   <a:srgbClr val="071A2B"/>
                 </a:solidFill>
@@ -20342,97 +20414,31 @@
                 <a:ea typeface="Apple SD Gothic Neo"/>
                 <a:cs typeface="Apple SD Gothic Neo"/>
               </a:rPr>
-              <a:t>사용자 인터페이스</a:t>
-            </a:r>
-          </a:p>
-        </p:txBody>
-      </p:sp>
-      <p:sp>
-        <p:nvSpPr>
-          <p:cNvPr id="14" name="slide3-panel-02">
-            <a:extLst xmlns:a="http://schemas.openxmlformats.org/drawingml/2006/main">
-              <a:ext uri="{FF2B5EF4-FFF2-40B4-BE49-F238E27FC236}">
-                <a16:creationId xmlns:a16="http://schemas.microsoft.com/office/drawing/2014/main" id="{3889836B-4F4B-43AC-9B8A-7622318EF3F9}"/>
-              </a:ext>
-            </a:extLst>
-          </p:cNvPr>
-          <p:cNvSpPr>
-            <a:spLocks xmlns:a="http://schemas.openxmlformats.org/drawingml/2006/main" noGrp="1"/>
-          </p:cNvSpPr>
-          <p:nvPr/>
-        </p:nvSpPr>
-        <p:spPr>
-          <a:xfrm xmlns:a="http://schemas.openxmlformats.org/drawingml/2006/main">
-            <a:off x="4257675" y="2990850"/>
-            <a:ext cx="3200400" cy="2057400"/>
-          </a:xfrm>
-          <a:prstGeom xmlns:a="http://schemas.openxmlformats.org/drawingml/2006/main" prst="rect">
-            <a:avLst/>
-          </a:prstGeom>
-          <a:solidFill xmlns:a="http://schemas.openxmlformats.org/drawingml/2006/main">
-            <a:srgbClr val="F3F6F8"/>
-          </a:solidFill>
-          <a:ln xmlns:a="http://schemas.openxmlformats.org/drawingml/2006/main" w="0">
-            <a:noFill/>
-            <a:prstDash val="solid"/>
-          </a:ln>
-        </p:spPr>
-      </p:sp>
-      <p:sp>
-        <p:nvSpPr>
-          <p:cNvPr id="15" name="slide3-card-title-02">
-            <a:extLst xmlns:a="http://schemas.openxmlformats.org/drawingml/2006/main">
-              <a:ext uri="{FF2B5EF4-FFF2-40B4-BE49-F238E27FC236}">
-                <a16:creationId xmlns:a16="http://schemas.microsoft.com/office/drawing/2014/main" id="{1287FDDF-BCAD-4F43-B0B0-7BED9E28DC2B}"/>
-              </a:ext>
-            </a:extLst>
-          </p:cNvPr>
-          <p:cNvSpPr>
-            <a:spLocks xmlns:a="http://schemas.openxmlformats.org/drawingml/2006/main" noGrp="1"/>
-          </p:cNvSpPr>
-          <p:nvPr/>
-        </p:nvSpPr>
-        <p:spPr>
-          <a:xfrm xmlns:a="http://schemas.openxmlformats.org/drawingml/2006/main">
-            <a:off x="4486275" y="3276600"/>
-            <a:ext cx="2743200" cy="571500"/>
-          </a:xfrm>
-          <a:prstGeom xmlns:a="http://schemas.openxmlformats.org/drawingml/2006/main" prst="rect">
-            <a:avLst/>
-          </a:prstGeom>
-          <a:noFill xmlns:a="http://schemas.openxmlformats.org/drawingml/2006/main"/>
-          <a:ln xmlns:a="http://schemas.openxmlformats.org/drawingml/2006/main" w="0">
-            <a:noFill/>
-            <a:prstDash val="solid"/>
-          </a:ln>
-        </p:spPr>
-        <p:txBody>
-          <a:bodyPr xmlns:a="http://schemas.openxmlformats.org/drawingml/2006/main" wrap="square" lIns="0" tIns="0" rIns="0" bIns="0" anchor="t">
-            <a:noAutofit/>
-          </a:bodyPr>
-          <a:lstStyle xmlns:a="http://schemas.openxmlformats.org/drawingml/2006/main"/>
+              <a:t>함께 달릴 때,</a:t>
+            </a:r>
+          </a:p>
           <a:p xmlns:a="http://schemas.openxmlformats.org/drawingml/2006/main">
             <a:pPr algn="ctr">
               <a:buNone/>
-              <a:defRPr sz="1650" b="1">
-                <a:solidFill>
-                  <a:srgbClr val="0A0A0A"/>
-                </a:solidFill>
-                <a:latin typeface="Apple SD Gothic Neo"/>
-                <a:ea typeface="Apple SD Gothic Neo"/>
-                <a:cs typeface="Apple SD Gothic Neo"/>
-              </a:defRPr>
-            </a:pPr>
-            <a:r>
-              <a:rPr sz="1650" b="1">
-                <a:solidFill>
-                  <a:srgbClr val="0A0A0A"/>
-                </a:solidFill>
-                <a:latin typeface="Apple SD Gothic Neo"/>
-                <a:ea typeface="Apple SD Gothic Neo"/>
-                <a:cs typeface="Apple SD Gothic Neo"/>
-              </a:rPr>
-              <a:t>입력과 멀티모달 출력</a:t>
+              <a:defRPr sz="3000" b="1">
+                <a:solidFill>
+                  <a:srgbClr val="071A2B"/>
+                </a:solidFill>
+                <a:latin typeface="Apple SD Gothic Neo"/>
+                <a:ea typeface="Apple SD Gothic Neo"/>
+                <a:cs typeface="Apple SD Gothic Neo"/>
+              </a:defRPr>
+            </a:pPr>
+            <a:r>
+              <a:rPr sz="3000" b="1">
+                <a:solidFill>
+                  <a:srgbClr val="071A2B"/>
+                </a:solidFill>
+                <a:latin typeface="Apple SD Gothic Neo"/>
+                <a:ea typeface="Apple SD Gothic Neo"/>
+                <a:cs typeface="Apple SD Gothic Neo"/>
+              </a:rPr>
+              <a:t>안전 정보도 함께 움직입니다</a:t>
             </a:r>
           </a:p>
         </p:txBody>
@@ -20453,8 +20459,8 @@
         </p:nvSpPr>
         <p:spPr>
           <a:xfrm xmlns:a="http://schemas.openxmlformats.org/drawingml/2006/main">
-            <a:off x="4486275" y="4057650"/>
-            <a:ext cx="2743200" cy="685800"/>
+            <a:off x="1619250" y="3943350"/>
+            <a:ext cx="8953500" cy="457200"/>
           </a:xfrm>
           <a:prstGeom xmlns:a="http://schemas.openxmlformats.org/drawingml/2006/main" prst="rect">
             <a:avLst/>
@@ -20475,7 +20481,7 @@
               <a:buNone/>
               <a:defRPr sz="1350" b="0">
                 <a:solidFill>
-                  <a:srgbClr val="5B6472"/>
+                  <a:srgbClr val="667085"/>
                 </a:solidFill>
                 <a:latin typeface="Apple SD Gothic Neo"/>
                 <a:ea typeface="Apple SD Gothic Neo"/>
@@ -20485,37 +20491,13 @@
             <a:r>
               <a:rPr sz="1350" b="0">
                 <a:solidFill>
-                  <a:srgbClr val="5B6472"/>
-                </a:solidFill>
-                <a:latin typeface="Apple SD Gothic Neo"/>
-                <a:ea typeface="Apple SD Gothic Neo"/>
-                <a:cs typeface="Apple SD Gothic Neo"/>
-              </a:rPr>
-              <a:t>Button·RGB·Buzzer·OLED</a:t>
-            </a:r>
-          </a:p>
-          <a:p xmlns:a="http://schemas.openxmlformats.org/drawingml/2006/main">
-            <a:pPr algn="ctr">
-              <a:buNone/>
-              <a:defRPr sz="1350" b="0">
-                <a:solidFill>
-                  <a:srgbClr val="5B6472"/>
-                </a:solidFill>
-                <a:latin typeface="Apple SD Gothic Neo"/>
-                <a:ea typeface="Apple SD Gothic Neo"/>
-                <a:cs typeface="Apple SD Gothic Neo"/>
-              </a:defRPr>
-            </a:pPr>
-            <a:r>
-              <a:rPr sz="1350" b="0">
-                <a:solidFill>
-                  <a:srgbClr val="5B6472"/>
-                </a:solidFill>
-                <a:latin typeface="Apple SD Gothic Neo"/>
-                <a:ea typeface="Apple SD Gothic Neo"/>
-                <a:cs typeface="Apple SD Gothic Neo"/>
-              </a:rPr>
-              <a:t>VS1003B Driver·Service</a:t>
+                  <a:srgbClr val="667085"/>
+                </a:solidFill>
+                <a:latin typeface="Apple SD Gothic Neo"/>
+                <a:ea typeface="Apple SD Gothic Neo"/>
+                <a:cs typeface="Apple SD Gothic Neo"/>
+              </a:rPr>
+              <a:t>개발 역할  |  안전 감지 · 사용자 인터페이스 · 무선 통합</a:t>
             </a:r>
           </a:p>
         </p:txBody>
@@ -20624,7 +20606,7 @@
         </p:nvSpPr>
         <p:spPr>
           <a:xfrm xmlns:a="http://schemas.openxmlformats.org/drawingml/2006/main">
-            <a:off x="8115300" y="2495550"/>
+            <a:off x="8115300" y="2171700"/>
             <a:ext cx="3200400" cy="304800"/>
           </a:xfrm>
           <a:prstGeom xmlns:a="http://schemas.openxmlformats.org/drawingml/2006/main" prst="rect">
@@ -20646,7 +20628,7 @@
               <a:buNone/>
               <a:defRPr sz="1800" b="1">
                 <a:solidFill>
-                  <a:srgbClr val="FF6B6B"/>
+                  <a:srgbClr val="7C6CF2"/>
                 </a:solidFill>
                 <a:latin typeface="Apple SD Gothic Neo"/>
                 <a:ea typeface="Apple SD Gothic Neo"/>
@@ -20656,13 +20638,13 @@
             <a:r>
               <a:rPr sz="1800" b="1">
                 <a:solidFill>
-                  <a:srgbClr val="FF6B6B"/>
-                </a:solidFill>
-                <a:latin typeface="Apple SD Gothic Neo"/>
-                <a:ea typeface="Apple SD Gothic Neo"/>
-                <a:cs typeface="Apple SD Gothic Neo"/>
-              </a:rPr>
-              <a:t>무선·통합</a:t>
+                  <a:srgbClr val="7C6CF2"/>
+                </a:solidFill>
+                <a:latin typeface="Apple SD Gothic Neo"/>
+                <a:ea typeface="Apple SD Gothic Neo"/>
+                <a:cs typeface="Apple SD Gothic Neo"/>
+              </a:rPr>
+              <a:t/>
             </a:r>
           </a:p>
         </p:txBody>
@@ -20683,15 +20665,13 @@
         </p:nvSpPr>
         <p:spPr>
           <a:xfrm xmlns:a="http://schemas.openxmlformats.org/drawingml/2006/main">
-            <a:off x="8115300" y="2990850"/>
-            <a:ext cx="3200400" cy="2057400"/>
-          </a:xfrm>
-          <a:prstGeom xmlns:a="http://schemas.openxmlformats.org/drawingml/2006/main" prst="rect">
-            <a:avLst/>
-          </a:prstGeom>
-          <a:solidFill xmlns:a="http://schemas.openxmlformats.org/drawingml/2006/main">
-            <a:srgbClr val="F3F6F8"/>
-          </a:solidFill>
+            <a:off x="8115300" y="3333750"/>
+            <a:ext cx="3200400" cy="1714500"/>
+          </a:xfrm>
+          <a:prstGeom xmlns:a="http://schemas.openxmlformats.org/drawingml/2006/main" prst="rect">
+            <a:avLst/>
+          </a:prstGeom>
+          <a:noFill xmlns:a="http://schemas.openxmlformats.org/drawingml/2006/main"/>
           <a:ln xmlns:a="http://schemas.openxmlformats.org/drawingml/2006/main" w="0">
             <a:noFill/>
             <a:prstDash val="solid"/>
@@ -20714,7 +20694,7 @@
         </p:nvSpPr>
         <p:spPr>
           <a:xfrm xmlns:a="http://schemas.openxmlformats.org/drawingml/2006/main">
-            <a:off x="8343900" y="3276600"/>
+            <a:off x="8343900" y="3600450"/>
             <a:ext cx="2743200" cy="571500"/>
           </a:xfrm>
           <a:prstGeom xmlns:a="http://schemas.openxmlformats.org/drawingml/2006/main" prst="rect">
@@ -20752,7 +20732,7 @@
                 <a:ea typeface="Apple SD Gothic Neo"/>
                 <a:cs typeface="Apple SD Gothic Neo"/>
               </a:rPr>
-              <a:t>ESP32-S3 Mesh Bridge</a:t>
+              <a:t/>
             </a:r>
           </a:p>
         </p:txBody>
@@ -20773,8 +20753,8 @@
         </p:nvSpPr>
         <p:spPr>
           <a:xfrm xmlns:a="http://schemas.openxmlformats.org/drawingml/2006/main">
-            <a:off x="8343900" y="4057650"/>
-            <a:ext cx="2743200" cy="685800"/>
+            <a:off x="8343900" y="4324350"/>
+            <a:ext cx="2743200" cy="533400"/>
           </a:xfrm>
           <a:prstGeom xmlns:a="http://schemas.openxmlformats.org/drawingml/2006/main" prst="rect">
             <a:avLst/>
@@ -20811,31 +20791,7 @@
                 <a:ea typeface="Apple SD Gothic Neo"/>
                 <a:cs typeface="Apple SD Gothic Neo"/>
               </a:rPr>
-              <a:t>UART·Protocol·Queue</a:t>
-            </a:r>
-          </a:p>
-          <a:p xmlns:a="http://schemas.openxmlformats.org/drawingml/2006/main">
-            <a:pPr algn="ctr">
-              <a:buNone/>
-              <a:defRPr sz="1350" b="0">
-                <a:solidFill>
-                  <a:srgbClr val="5B6472"/>
-                </a:solidFill>
-                <a:latin typeface="Apple SD Gothic Neo"/>
-                <a:ea typeface="Apple SD Gothic Neo"/>
-                <a:cs typeface="Apple SD Gothic Neo"/>
-              </a:defRPr>
-            </a:pPr>
-            <a:r>
-              <a:rPr sz="1350" b="0">
-                <a:solidFill>
-                  <a:srgbClr val="5B6472"/>
-                </a:solidFill>
-                <a:latin typeface="Apple SD Gothic Neo"/>
-                <a:ea typeface="Apple SD Gothic Neo"/>
-                <a:cs typeface="Apple SD Gothic Neo"/>
-              </a:rPr>
-              <a:t>Provisioning Support·Demo 통합</a:t>
+              <a:t/>
             </a:r>
           </a:p>
         </p:txBody>
@@ -20927,7 +20883,7 @@
                 <a:ea typeface="Apple SD Gothic Neo"/>
                 <a:cs typeface="Apple SD Gothic Neo"/>
               </a:rPr>
-              <a:t>공동 업무</a:t>
+              <a:t>자료 링크</a:t>
             </a:r>
           </a:p>
         </p:txBody>
@@ -20986,7 +20942,53 @@
                 <a:ea typeface="Apple SD Gothic Neo"/>
                 <a:cs typeface="Apple SD Gothic Neo"/>
               </a:rPr>
-              <a:t>핀·전원 통합 · Host Check · 3노드 검증 계획 · 현장 Demo 운영</a:t>
+              <a:t>[</a:t>
+            </a:r>
+            <a:r>
+              <a:rPr sz="1500" b="1">
+                <a:solidFill>
+                  <a:srgbClr val="FFFFFF"/>
+                </a:solidFill>
+                <a:latin typeface="Apple SD Gothic Neo"/>
+                <a:ea typeface="Apple SD Gothic Neo"/>
+                <a:cs typeface="Apple SD Gothic Neo"/>
+                <a:hlinkClick xmlns:r="http://schemas.openxmlformats.org/officeDocument/2006/relationships" r:id="R59bdec533d4e4348"/>
+              </a:rPr>
+              <a:t>소스코드</a:t>
+            </a:r>
+            <a:r>
+              <a:rPr sz="1500" b="1">
+                <a:solidFill>
+                  <a:srgbClr val="FFFFFF"/>
+                </a:solidFill>
+                <a:latin typeface="Apple SD Gothic Neo"/>
+                <a:ea typeface="Apple SD Gothic Neo"/>
+                <a:cs typeface="Apple SD Gothic Neo"/>
+              </a:rPr>
+              <a:t>]   ·   [</a:t>
+            </a:r>
+            <a:r>
+              <a:rPr sz="1500" b="1">
+                <a:solidFill>
+                  <a:srgbClr val="FFFFFF"/>
+                </a:solidFill>
+                <a:latin typeface="Apple SD Gothic Neo"/>
+                <a:ea typeface="Apple SD Gothic Neo"/>
+                <a:cs typeface="Apple SD Gothic Neo"/>
+                <a:hlinkClick xmlns:r="http://schemas.openxmlformats.org/officeDocument/2006/relationships" r:id="R0fd784aa145e4595"/>
+              </a:rPr>
+              <a:t>공모전 예선 시연영상 NOSTOS</a:t>
+            </a:r>
+            <a:r>
+              <a:rPr sz="1500" b="1">
+                <a:solidFill>
+                  <a:srgbClr val="FFFFFF"/>
+                </a:solidFill>
+                <a:latin typeface="Apple SD Gothic Neo"/>
+                <a:ea typeface="Apple SD Gothic Neo"/>
+                <a:cs typeface="Apple SD Gothic Neo"/>
+              </a:rPr>
+              <a:t>]</a:t>
             </a:r>
           </a:p>
         </p:txBody>
@@ -24138,7 +24140,7 @@
                 <a:latin typeface="Apple SD Gothic Neo"/>
                 <a:ea typeface="Apple SD Gothic Neo"/>
                 <a:cs typeface="Apple SD Gothic Neo"/>
-                <a:hlinkClick xmlns:r="http://schemas.openxmlformats.org/officeDocument/2006/relationships" r:id="R4e94f304393f4ada"/>
+                <a:hlinkClick xmlns:r="http://schemas.openxmlformats.org/officeDocument/2006/relationships" r:id="R637ba488e46145c0"/>
               </a:rPr>
               <a:t>GitHub Repository</a:t>
             </a:r>
@@ -24161,7 +24163,7 @@
                 <a:latin typeface="Apple SD Gothic Neo"/>
                 <a:ea typeface="Apple SD Gothic Neo"/>
                 <a:cs typeface="Apple SD Gothic Neo"/>
-                <a:hlinkClick xmlns:r="http://schemas.openxmlformats.org/officeDocument/2006/relationships" r:id="R5c74347dd2cf4d10"/>
+                <a:hlinkClick xmlns:r="http://schemas.openxmlformats.org/officeDocument/2006/relationships" r:id="R7ca9024038634521"/>
               </a:rPr>
               <a:t>NOSTOS Ride Signals</a:t>
             </a:r>

</xml_diff>